<commit_message>
def setup inicial creeper
</commit_message>
<xml_diff>
--- a/python/creeper/presentacion.pptx
+++ b/python/creeper/presentacion.pptx
@@ -10,11 +10,4 @@
 </file>
 
 <file path=ppt/slides/slide1.xml><?xml version="1.0" encoding="UTF-8" standalone="yes"?><p:sld xmlns:p="http://schemas.openxmlformats.org/presentationml/2006/main"><p:cSld><p:spTree><p:nvGrpSpPr><p:nvPr><p:cNvPr id="1" name=""/></p:nvPr></p:nvGrpSpPr><p:grpSpPr><a:xfrm xmlns:a="http://schemas.openxmlformats.org/drawingml/2006/main"><a:off x="0" y="0"/><a:ext cx="0" cy="0"/></a:xfrm></p:grpSpPr><p:sp><p:nvSpPr><p:cNvPr id="2" name="Title"/><p:nvSpPrType spPr="true"/></p:nvSpPr><p:spPr><a:xfrm xmlns:a="http://schemas.openxmlformats.org/drawingml/2006/main"><a:off x="685800" y="457200"/><a:ext cx="7772400" cy="1219200"/></a:xfrm></p:spPr><p:txBody><a:bodyPr/><a:p><a:r><a:rPr lang="es-AR" sz="4400"/><a:t>Creeper Virus Lab</a:t></a:r></a:p></p:txBody></p:sp></p:spTree></p:cSld></p:sld>
-</file>
-
-<file path=creeper_infection/.creeper_marker.txt>CREEPER VIRUS - INFECTION MARKER
-Timestamp: 2026-07-08 17:47:49.805875
-Original file: presentacion.pptx
-This file was infected by the Creeper educational virus.
-
 </file>
</xml_diff>